<commit_message>
Correção pitch e readme
</commit_message>
<xml_diff>
--- a/docs/Pitch.pptx
+++ b/docs/Pitch.pptx
@@ -1074,7 +1074,7 @@
           <a:p>
             <a:fld id="{C764DE79-268F-4C1A-8933-263129D2AF90}" type="datetimeFigureOut">
               <a:rPr lang="en-US" smtClean="0"/>
-              <a:t>6/8/2026</a:t>
+              <a:t>6/9/2026</a:t>
             </a:fld>
             <a:endParaRPr lang="en-US" dirty="0"/>
           </a:p>
@@ -1245,7 +1245,7 @@
           <a:p>
             <a:fld id="{C764DE79-268F-4C1A-8933-263129D2AF90}" type="datetimeFigureOut">
               <a:rPr lang="en-US" smtClean="0"/>
-              <a:t>6/8/2026</a:t>
+              <a:t>6/9/2026</a:t>
             </a:fld>
             <a:endParaRPr lang="en-US" dirty="0"/>
           </a:p>
@@ -1426,7 +1426,7 @@
           <a:p>
             <a:fld id="{C764DE79-268F-4C1A-8933-263129D2AF90}" type="datetimeFigureOut">
               <a:rPr lang="en-US" smtClean="0"/>
-              <a:t>6/8/2026</a:t>
+              <a:t>6/9/2026</a:t>
             </a:fld>
             <a:endParaRPr lang="en-US" dirty="0"/>
           </a:p>
@@ -1632,7 +1632,7 @@
           <a:p>
             <a:fld id="{C764DE79-268F-4C1A-8933-263129D2AF90}" type="datetimeFigureOut">
               <a:rPr lang="en-US" smtClean="0"/>
-              <a:t>6/8/2026</a:t>
+              <a:t>6/9/2026</a:t>
             </a:fld>
             <a:endParaRPr lang="en-US" dirty="0"/>
           </a:p>
@@ -1879,7 +1879,7 @@
           <a:p>
             <a:fld id="{C764DE79-268F-4C1A-8933-263129D2AF90}" type="datetimeFigureOut">
               <a:rPr lang="en-US" smtClean="0"/>
-              <a:t>6/8/2026</a:t>
+              <a:t>6/9/2026</a:t>
             </a:fld>
             <a:endParaRPr lang="en-US" dirty="0"/>
           </a:p>
@@ -2112,7 +2112,7 @@
           <a:p>
             <a:fld id="{C764DE79-268F-4C1A-8933-263129D2AF90}" type="datetimeFigureOut">
               <a:rPr lang="en-US" smtClean="0"/>
-              <a:t>6/8/2026</a:t>
+              <a:t>6/9/2026</a:t>
             </a:fld>
             <a:endParaRPr lang="en-US" dirty="0"/>
           </a:p>
@@ -2480,7 +2480,7 @@
           <a:p>
             <a:fld id="{C764DE79-268F-4C1A-8933-263129D2AF90}" type="datetimeFigureOut">
               <a:rPr lang="en-US" smtClean="0"/>
-              <a:t>6/8/2026</a:t>
+              <a:t>6/9/2026</a:t>
             </a:fld>
             <a:endParaRPr lang="en-US" dirty="0"/>
           </a:p>
@@ -2599,7 +2599,7 @@
           <a:p>
             <a:fld id="{C764DE79-268F-4C1A-8933-263129D2AF90}" type="datetimeFigureOut">
               <a:rPr lang="en-US" smtClean="0"/>
-              <a:t>6/8/2026</a:t>
+              <a:t>6/9/2026</a:t>
             </a:fld>
             <a:endParaRPr lang="en-US" dirty="0"/>
           </a:p>
@@ -2695,7 +2695,7 @@
           <a:p>
             <a:fld id="{C764DE79-268F-4C1A-8933-263129D2AF90}" type="datetimeFigureOut">
               <a:rPr lang="en-US" smtClean="0"/>
-              <a:t>6/8/2026</a:t>
+              <a:t>6/9/2026</a:t>
             </a:fld>
             <a:endParaRPr lang="en-US" dirty="0"/>
           </a:p>
@@ -2973,7 +2973,7 @@
           <a:p>
             <a:fld id="{C764DE79-268F-4C1A-8933-263129D2AF90}" type="datetimeFigureOut">
               <a:rPr lang="en-US" smtClean="0"/>
-              <a:t>6/8/2026</a:t>
+              <a:t>6/9/2026</a:t>
             </a:fld>
             <a:endParaRPr lang="en-US" dirty="0"/>
           </a:p>
@@ -3231,7 +3231,7 @@
           <a:p>
             <a:fld id="{C764DE79-268F-4C1A-8933-263129D2AF90}" type="datetimeFigureOut">
               <a:rPr lang="en-US" smtClean="0"/>
-              <a:t>6/8/2026</a:t>
+              <a:t>6/9/2026</a:t>
             </a:fld>
             <a:endParaRPr lang="en-US" dirty="0"/>
           </a:p>
@@ -3445,7 +3445,7 @@
           <a:p>
             <a:fld id="{C764DE79-268F-4C1A-8933-263129D2AF90}" type="datetimeFigureOut">
               <a:rPr lang="en-US" smtClean="0"/>
-              <a:t>6/8/2026</a:t>
+              <a:t>6/9/2026</a:t>
             </a:fld>
             <a:endParaRPr lang="en-US" dirty="0"/>
           </a:p>
@@ -7069,13 +7069,13 @@
       </p:sp>
       <p:sp>
         <p:nvSpPr>
-          <p:cNvPr id="10" name="Shape 8"/>
-          <p:cNvSpPr/>
-          <p:nvPr/>
-        </p:nvSpPr>
-        <p:spPr>
-          <a:xfrm>
-            <a:off x="685800" y="2459736"/>
+          <p:cNvPr id="12" name="Shape 10"/>
+          <p:cNvSpPr/>
+          <p:nvPr/>
+        </p:nvSpPr>
+        <p:spPr>
+          <a:xfrm>
+            <a:off x="690372" y="2590078"/>
             <a:ext cx="73152" cy="73152"/>
           </a:xfrm>
           <a:prstGeom prst="ellipse">
@@ -7095,23 +7095,19 @@
           <a:bodyPr/>
           <a:lstStyle/>
           <a:p>
-            <a:endParaRPr lang="pt-BR">
-              <a:solidFill>
-                <a:srgbClr val="0070C0"/>
-              </a:solidFill>
-            </a:endParaRPr>
-          </a:p>
-        </p:txBody>
-      </p:sp>
-      <p:sp>
-        <p:nvSpPr>
-          <p:cNvPr id="11" name="Text 9"/>
-          <p:cNvSpPr/>
-          <p:nvPr/>
-        </p:nvSpPr>
-        <p:spPr>
-          <a:xfrm>
-            <a:off x="841248" y="2322576"/>
+            <a:endParaRPr lang="pt-BR"/>
+          </a:p>
+        </p:txBody>
+      </p:sp>
+      <p:sp>
+        <p:nvSpPr>
+          <p:cNvPr id="13" name="Text 11"/>
+          <p:cNvSpPr/>
+          <p:nvPr/>
+        </p:nvSpPr>
+        <p:spPr>
+          <a:xfrm>
+            <a:off x="845820" y="2452918"/>
             <a:ext cx="3337560" cy="347472"/>
           </a:xfrm>
           <a:prstGeom prst="rect">
@@ -7133,7 +7129,7 @@
                 <a:ea typeface="Inter" pitchFamily="34" charset="-122"/>
                 <a:cs typeface="Inter" pitchFamily="34" charset="-120"/>
               </a:rPr>
-              <a:t>Nível atual do </a:t>
+              <a:t>Hora do </a:t>
             </a:r>
             <a:r>
               <a:rPr lang="en-US" sz="1050" dirty="0" err="1">
@@ -7141,15 +7137,7 @@
                 <a:ea typeface="Inter" pitchFamily="34" charset="-122"/>
                 <a:cs typeface="Inter" pitchFamily="34" charset="-120"/>
               </a:rPr>
-              <a:t>reservatório</a:t>
-            </a:r>
-            <a:r>
-              <a:rPr lang="en-US" sz="1050" dirty="0">
-                <a:latin typeface="Inter" pitchFamily="34" charset="0"/>
-                <a:ea typeface="Inter" pitchFamily="34" charset="-122"/>
-                <a:cs typeface="Inter" pitchFamily="34" charset="-120"/>
-              </a:rPr>
-              <a:t> (%)</a:t>
+              <a:t>dia</a:t>
             </a:r>
             <a:endParaRPr lang="en-US" sz="1050" dirty="0"/>
           </a:p>
@@ -7157,13 +7145,13 @@
       </p:sp>
       <p:sp>
         <p:nvSpPr>
-          <p:cNvPr id="12" name="Shape 10"/>
-          <p:cNvSpPr/>
-          <p:nvPr/>
-        </p:nvSpPr>
-        <p:spPr>
-          <a:xfrm>
-            <a:off x="685800" y="2935224"/>
+          <p:cNvPr id="14" name="Shape 12"/>
+          <p:cNvSpPr/>
+          <p:nvPr/>
+        </p:nvSpPr>
+        <p:spPr>
+          <a:xfrm>
+            <a:off x="690372" y="3065566"/>
             <a:ext cx="73152" cy="73152"/>
           </a:xfrm>
           <a:prstGeom prst="ellipse">
@@ -7189,13 +7177,13 @@
       </p:sp>
       <p:sp>
         <p:nvSpPr>
-          <p:cNvPr id="13" name="Text 11"/>
-          <p:cNvSpPr/>
-          <p:nvPr/>
-        </p:nvSpPr>
-        <p:spPr>
-          <a:xfrm>
-            <a:off x="841248" y="2798064"/>
+          <p:cNvPr id="15" name="Text 13"/>
+          <p:cNvSpPr/>
+          <p:nvPr/>
+        </p:nvSpPr>
+        <p:spPr>
+          <a:xfrm>
+            <a:off x="845820" y="2928406"/>
             <a:ext cx="3337560" cy="347472"/>
           </a:xfrm>
           <a:prstGeom prst="rect">
@@ -7217,7 +7205,7 @@
                 <a:ea typeface="Inter" pitchFamily="34" charset="-122"/>
                 <a:cs typeface="Inter" pitchFamily="34" charset="-120"/>
               </a:rPr>
-              <a:t>Hora do </a:t>
+              <a:t>Dia da </a:t>
             </a:r>
             <a:r>
               <a:rPr lang="en-US" sz="1050" dirty="0" err="1">
@@ -7225,7 +7213,7 @@
                 <a:ea typeface="Inter" pitchFamily="34" charset="-122"/>
                 <a:cs typeface="Inter" pitchFamily="34" charset="-120"/>
               </a:rPr>
-              <a:t>dia</a:t>
+              <a:t>semana</a:t>
             </a:r>
             <a:endParaRPr lang="en-US" sz="1050" dirty="0"/>
           </a:p>
@@ -7233,13 +7221,13 @@
       </p:sp>
       <p:sp>
         <p:nvSpPr>
-          <p:cNvPr id="14" name="Shape 12"/>
-          <p:cNvSpPr/>
-          <p:nvPr/>
-        </p:nvSpPr>
-        <p:spPr>
-          <a:xfrm>
-            <a:off x="685800" y="3410712"/>
+          <p:cNvPr id="16" name="Shape 14"/>
+          <p:cNvSpPr/>
+          <p:nvPr/>
+        </p:nvSpPr>
+        <p:spPr>
+          <a:xfrm>
+            <a:off x="690372" y="3541054"/>
             <a:ext cx="73152" cy="73152"/>
           </a:xfrm>
           <a:prstGeom prst="ellipse">
@@ -7265,89 +7253,13 @@
       </p:sp>
       <p:sp>
         <p:nvSpPr>
-          <p:cNvPr id="15" name="Text 13"/>
-          <p:cNvSpPr/>
-          <p:nvPr/>
-        </p:nvSpPr>
-        <p:spPr>
-          <a:xfrm>
-            <a:off x="841248" y="3273552"/>
-            <a:ext cx="3337560" cy="347472"/>
-          </a:xfrm>
-          <a:prstGeom prst="rect">
-            <a:avLst/>
-          </a:prstGeom>
-          <a:noFill/>
-          <a:ln/>
-        </p:spPr>
-        <p:txBody>
-          <a:bodyPr wrap="square" lIns="0" tIns="0" rIns="0" bIns="0" rtlCol="0" anchor="ctr"/>
-          <a:lstStyle/>
-          <a:p>
-            <a:pPr marL="0" indent="0" algn="l">
-              <a:buNone/>
-            </a:pPr>
-            <a:r>
-              <a:rPr lang="en-US" sz="1050" dirty="0">
-                <a:latin typeface="Inter" pitchFamily="34" charset="0"/>
-                <a:ea typeface="Inter" pitchFamily="34" charset="-122"/>
-                <a:cs typeface="Inter" pitchFamily="34" charset="-120"/>
-              </a:rPr>
-              <a:t>Dia da </a:t>
-            </a:r>
-            <a:r>
-              <a:rPr lang="en-US" sz="1050" dirty="0" err="1">
-                <a:latin typeface="Inter" pitchFamily="34" charset="0"/>
-                <a:ea typeface="Inter" pitchFamily="34" charset="-122"/>
-                <a:cs typeface="Inter" pitchFamily="34" charset="-120"/>
-              </a:rPr>
-              <a:t>semana</a:t>
-            </a:r>
-            <a:endParaRPr lang="en-US" sz="1050" dirty="0"/>
-          </a:p>
-        </p:txBody>
-      </p:sp>
-      <p:sp>
-        <p:nvSpPr>
-          <p:cNvPr id="16" name="Shape 14"/>
-          <p:cNvSpPr/>
-          <p:nvPr/>
-        </p:nvSpPr>
-        <p:spPr>
-          <a:xfrm>
-            <a:off x="685800" y="3886200"/>
-            <a:ext cx="73152" cy="73152"/>
-          </a:xfrm>
-          <a:prstGeom prst="ellipse">
-            <a:avLst/>
-          </a:prstGeom>
-          <a:solidFill>
-            <a:srgbClr val="0070C0"/>
-          </a:solidFill>
-          <a:ln w="12700">
-            <a:solidFill>
-              <a:srgbClr val="0070C0"/>
-            </a:solidFill>
-            <a:prstDash val="solid"/>
-          </a:ln>
-        </p:spPr>
-        <p:txBody>
-          <a:bodyPr/>
-          <a:lstStyle/>
-          <a:p>
-            <a:endParaRPr lang="pt-BR"/>
-          </a:p>
-        </p:txBody>
-      </p:sp>
-      <p:sp>
-        <p:nvSpPr>
           <p:cNvPr id="17" name="Text 15"/>
           <p:cNvSpPr/>
           <p:nvPr/>
         </p:nvSpPr>
         <p:spPr>
           <a:xfrm>
-            <a:off x="841248" y="3749040"/>
+            <a:off x="845820" y="3403894"/>
             <a:ext cx="3337560" cy="347472"/>
           </a:xfrm>
           <a:prstGeom prst="rect">
@@ -9289,7 +9201,7 @@
                 <a:ea typeface="Inter" pitchFamily="34" charset="-122"/>
                 <a:cs typeface="Inter" pitchFamily="34" charset="-120"/>
               </a:rPr>
-              <a:t>Análise das métricas MAE e RMSE</a:t>
+              <a:t>Análise das métricas MAE, RMSE e R²</a:t>
             </a:r>
             <a:endParaRPr lang="en-US" sz="950" dirty="0">
               <a:solidFill>
@@ -9874,7 +9786,7 @@
         </p:nvSpPr>
         <p:spPr>
           <a:xfrm>
-            <a:off x="637045" y="3891789"/>
+            <a:off x="629420" y="3120264"/>
             <a:ext cx="1190477" cy="541272"/>
           </a:xfrm>
           <a:prstGeom prst="roundRect">
@@ -9920,7 +9832,7 @@
         </p:nvSpPr>
         <p:spPr>
           <a:xfrm>
-            <a:off x="637045" y="3891789"/>
+            <a:off x="629420" y="3120264"/>
             <a:ext cx="1190477" cy="541272"/>
           </a:xfrm>
           <a:prstGeom prst="rect">
@@ -9988,72 +9900,6 @@
               </a:rPr>
               <a:t> hora</a:t>
             </a:r>
-          </a:p>
-        </p:txBody>
-      </p:sp>
-      <p:sp>
-        <p:nvSpPr>
-          <p:cNvPr id="22" name="Shape 13">
-            <a:extLst>
-              <a:ext uri="{FF2B5EF4-FFF2-40B4-BE49-F238E27FC236}">
-                <a16:creationId xmlns:a16="http://schemas.microsoft.com/office/drawing/2014/main" id="{A1EE35E9-874F-AD8D-D341-00D48C6CC809}"/>
-              </a:ext>
-            </a:extLst>
-          </p:cNvPr>
-          <p:cNvSpPr/>
-          <p:nvPr/>
-        </p:nvSpPr>
-        <p:spPr>
-          <a:xfrm>
-            <a:off x="629420" y="3118244"/>
-            <a:ext cx="1190477" cy="541272"/>
-          </a:xfrm>
-          <a:prstGeom prst="roundRect">
-            <a:avLst>
-              <a:gd name="adj" fmla="val 7778"/>
-            </a:avLst>
-          </a:prstGeom>
-          <a:solidFill>
-            <a:schemeClr val="accent3">
-              <a:lumMod val="60000"/>
-              <a:lumOff val="40000"/>
-            </a:schemeClr>
-          </a:solidFill>
-          <a:ln w="9525">
-            <a:solidFill>
-              <a:schemeClr val="accent3">
-                <a:lumMod val="60000"/>
-                <a:lumOff val="40000"/>
-              </a:schemeClr>
-            </a:solidFill>
-            <a:prstDash val="solid"/>
-          </a:ln>
-        </p:spPr>
-        <p:txBody>
-          <a:bodyPr anchor="ctr"/>
-          <a:lstStyle/>
-          <a:p>
-            <a:pPr algn="ctr"/>
-            <a:r>
-              <a:rPr lang="pt-BR" sz="1300" dirty="0">
-                <a:solidFill>
-                  <a:schemeClr val="bg2">
-                    <a:lumMod val="25000"/>
-                  </a:schemeClr>
-                </a:solidFill>
-                <a:latin typeface="Inter" pitchFamily="34" charset="0"/>
-                <a:ea typeface="Inter" pitchFamily="34" charset="-122"/>
-                <a:cs typeface="Inter" pitchFamily="34" charset="-120"/>
-              </a:rPr>
-              <a:t>Nível do reservatório</a:t>
-            </a:r>
-            <a:endParaRPr lang="en-US" sz="1300" dirty="0">
-              <a:solidFill>
-                <a:schemeClr val="bg2">
-                  <a:lumMod val="25000"/>
-                </a:schemeClr>
-              </a:solidFill>
-            </a:endParaRPr>
           </a:p>
         </p:txBody>
       </p:sp>

</xml_diff>